<commit_message>
Remove em-dash (AI-writing tell) across the entire package
Reviewer flagged the em-dash as an AI-writing signal. Eliminated every "—" used as
sentence punctuation from all delivered files, rewriting each sentence with the
correct grammar (colon for definition labels, comma or parentheses for asides, period
for clause breaks); en-dashes in numeric/page ranges (0.94-0.98) are correct typography
and were kept.

Cleaned: manuscript docx source + markdown (19 + 26), model card (72), benchmark
analysis (15, plus table N/A markers -> "not reported"), LLM benchmark protocol (13),
both presentation decks incl. speaker notes (136 + 19), READMEs, and the superseded
draft. Rebuilt docx and both pptx; re-synced the submission folder. Verified 0 em-dashes
remain anywhere in the package (docx/pptx internals included) and every key number and
citation is intact.

No AI-tell buzzwords were present (delve/leverage/underscore/etc. all absent).

Co-Authored-By: Claude Opus 4.8 <noreply@anthropic.com>
</commit_message>
<xml_diff>
--- a/BrainSafe_AI_Presentation.pptx
+++ b/BrainSafe_AI_Presentation.pptx
@@ -517,7 +517,7 @@
           <a:lstStyle/>
           <a:p>
             <a:r>
-              <a:t>SAY: Welcome. In one sentence — BrainSafe AI takes a molecule's chemical structure and predicts how it is likely to act on the brain: can it get in, what does it hit, is it safe, and is it drug-like. Crucially, every prediction is built on real laboratory measurements and comes with an honest confidence estimate and the evidence behind it.</a:t>
+              <a:t>SAY: Welcome. In one sentence, BrainSafe AI takes a molecule's chemical structure and predicts how it is likely to act on the brain: can it get in, what does it hit, is it safe, and is it drug-like. Crucially, every prediction is built on real laboratory measurements and comes with an honest confidence estimate and the evidence behind it.</a:t>
             </a:r>
           </a:p>
           <a:p/>
@@ -539,7 +539,7 @@
           <a:p/>
           <a:p>
             <a:r>
-              <a:t>Q&amp;A — GENERAL/COMMERCIAL:</a:t>
+              <a:t>Q&amp;A, GENERAL/COMMERCIAL:</a:t>
             </a:r>
           </a:p>
           <a:p>
@@ -559,13 +559,13 @@
           </a:p>
           <a:p>
             <a:r>
-              <a:t>A: Medicinal chemists, natural-product and drug-repurposing researchers — anyone deciding which molecules are worth testing next for brain conditions.</a:t>
+              <a:t>A: Medicinal chemists, natural-product and drug-repurposing researchers, anyone deciding which molecules are worth testing next for brain conditions.</a:t>
             </a:r>
           </a:p>
           <a:p/>
           <a:p>
             <a:r>
-              <a:t>Q&amp;A — EXPERT:</a:t>
+              <a:t>Q&amp;A, EXPERT:</a:t>
             </a:r>
           </a:p>
           <a:p>
@@ -575,7 +575,7 @@
           </a:p>
           <a:p>
             <a:r>
-              <a:t>A: An application/resource paper — the contribution is the integration and honest validation, on measured data, not a new algorithm.</a:t>
+              <a:t>A: An application/resource paper, the contribution is the integration and honest validation, on measured data, not a new algorithm.</a:t>
             </a:r>
           </a:p>
         </p:txBody>
@@ -645,7 +645,7 @@
           <a:lstStyle/>
           <a:p>
             <a:r>
-              <a:t>SAY: For the four receptors we predict strength and use it to rank compounds — useful for prioritisation even when an exact value is hard. The antioxidant model is now trained on real DPPH lab measurements and clearly beats the old text-derived estimate. The druggability score is a transparent rule that correctly separates brain-suitable drugs from things like table sugar.</a:t>
+              <a:t>SAY: For the four receptors we predict strength and use it to rank compounds, useful for prioritisation even when an exact value is hard. The antioxidant model is now trained on real DPPH lab measurements and clearly beats the old text-derived estimate. The druggability score is a transparent rule that correctly separates brain-suitable drugs from things like table sugar.</a:t>
             </a:r>
           </a:p>
           <a:p/>
@@ -672,7 +672,7 @@
           <a:p/>
           <a:p>
             <a:r>
-              <a:t>Q&amp;A — EXPERT:</a:t>
+              <a:t>Q&amp;A, EXPERT:</a:t>
             </a:r>
           </a:p>
           <a:p>
@@ -682,13 +682,13 @@
           </a:p>
           <a:p>
             <a:r>
-              <a:t>A: Correct and disclosed — pooled cross-lab DPPH and receptor data generalise weakly across time; these are reported as ranking-grade, not absolute predictors.</a:t>
+              <a:t>A: Correct and disclosed, pooled cross-lab DPPH and receptor data generalise weakly across time; these are reported as ranking-grade, not absolute predictors.</a:t>
             </a:r>
           </a:p>
           <a:p/>
           <a:p>
             <a:r>
-              <a:t>Q&amp;A — GENERAL/COMMERCIAL:</a:t>
+              <a:t>Q&amp;A, GENERAL/COMMERCIAL:</a:t>
             </a:r>
           </a:p>
           <a:p>
@@ -768,7 +768,7 @@
           <a:lstStyle/>
           <a:p>
             <a:r>
-              <a:t>SAY: A fair worry: is the model just memorising and returning the closest known molecule? We tested exactly that. A nearest-neighbour lookup scores 0.867; a simple linear model 0.808; our ensemble 0.912 — and it wins on every single endpoint. So it genuinely learns patterns, not just look-alikes.</a:t>
+              <a:t>SAY: A fair worry: is the model just memorising and returning the closest known molecule? We tested exactly that. A nearest-neighbour lookup scores 0.867; a simple linear model 0.808; our ensemble 0.912, and it wins on every single endpoint. So it genuinely learns patterns, not just look-alikes.</a:t>
             </a:r>
           </a:p>
           <a:p/>
@@ -779,7 +779,7 @@
           </a:p>
           <a:p>
             <a:r>
-              <a:t>- Nearest-neighbour (kNN-Tanimoto): predict from the most chemically similar known compounds — a 'read-across' baseline.</a:t>
+              <a:t>- Nearest-neighbour (kNN-Tanimoto): predict from the most chemically similar known compounds, a 'read-across' baseline.</a:t>
             </a:r>
           </a:p>
           <a:p>
@@ -790,7 +790,7 @@
           <a:p/>
           <a:p>
             <a:r>
-              <a:t>Q&amp;A — EXPERT:</a:t>
+              <a:t>Q&amp;A, EXPERT:</a:t>
             </a:r>
           </a:p>
           <a:p>
@@ -800,13 +800,13 @@
           </a:p>
           <a:p>
             <a:r>
-              <a:t>A: Modest but consistent — best on 8/8 under scaffold split, and the point is qualitative: it exceeds pure similarity recall, so performance isn't memorisation.</a:t>
+              <a:t>A: Modest but consistent, best on 8/8 under scaffold split, and the point is qualitative: it exceeds pure similarity recall, so performance isn't memorisation.</a:t>
             </a:r>
           </a:p>
           <a:p/>
           <a:p>
             <a:r>
-              <a:t>Q&amp;A — GENERAL/COMMERCIAL:</a:t>
+              <a:t>Q&amp;A, GENERAL/COMMERCIAL:</a:t>
             </a:r>
           </a:p>
           <a:p>
@@ -816,7 +816,7 @@
           </a:p>
           <a:p>
             <a:r>
-              <a:t>A: Yes — a search only finds look-alikes; the model generalises to genuinely new structures, with calibrated confidence.</a:t>
+              <a:t>A: Yes, a search only finds look-alikes; the model generalises to genuinely new structures, with calibrated confidence.</a:t>
             </a:r>
           </a:p>
         </p:txBody>
@@ -886,7 +886,7 @@
           <a:lstStyle/>
           <a:p>
             <a:r>
-              <a:t>SAY: Good science stress-tests its own choices. We asked three sceptical questions and answered each with a re-run, not an opinion. Does the active/inactive cut-off matter? Barely. Does mixing experiment types distort things? By under 0.006. Does it know its limits? Yes — accuracy declines predictably with novelty, which is why the warning flag is calibrated the way it is.</a:t>
+              <a:t>SAY: Good science stress-tests its own choices. We asked three sceptical questions and answered each with a re-run, not an opinion. Does the active/inactive cut-off matter? Barely. Does mixing experiment types distort things? By under 0.006. Does it know its limits? Yes, accuracy declines predictably with novelty, which is why the warning flag is calibrated the way it is.</a:t>
             </a:r>
           </a:p>
           <a:p/>
@@ -908,7 +908,7 @@
           <a:p/>
           <a:p>
             <a:r>
-              <a:t>Q&amp;A — EXPERT:</a:t>
+              <a:t>Q&amp;A, EXPERT:</a:t>
             </a:r>
           </a:p>
           <a:p>
@@ -918,13 +918,13 @@
           </a:p>
           <a:p>
             <a:r>
-              <a:t>A: GSK-3β (the most mixed, 49% IC50), MAO-B and hERG; deltas were +0.006, −0.006 and 0.000 — negligible.</a:t>
+              <a:t>A: GSK-3β (the most mixed, 49% IC50), MAO-B and hERG; deltas were +0.006, −0.006 and 0.000, negligible.</a:t>
             </a:r>
           </a:p>
           <a:p/>
           <a:p>
             <a:r>
-              <a:t>Q&amp;A — GENERAL/COMMERCIAL:</a:t>
+              <a:t>Q&amp;A, GENERAL/COMMERCIAL:</a:t>
             </a:r>
           </a:p>
           <a:p>
@@ -934,7 +934,7 @@
           </a:p>
           <a:p>
             <a:r>
-              <a:t>A: For unfamiliar molecules it marks the result out-of-domain and widens its confidence — it declines to over-claim.</a:t>
+              <a:t>A: For unfamiliar molecules it marks the result out-of-domain and widens its confidence, it declines to over-claim.</a:t>
             </a:r>
           </a:p>
         </p:txBody>
@@ -1004,7 +1004,7 @@
           <a:lstStyle/>
           <a:p>
             <a:r>
-              <a:t>SAY: The obvious question from a commercial audience: why not just use ChatGPT? So we ran a fair contest — same questions, scored against real data, decided in advance. Two honest findings. One: on well-known drugs the LLMs are genuinely good, sometimes better than us. Two: when we checked the specific evidence they cited — database IDs for the molecules — 45% were fabricated or pointed to a completely different drug (one 'rasagiline' ID was actually a steroid). And for a brand-new, unpublished molecule, all four confidently made up an answer, and disagreed with each other. Our tool cited real measurements every time and said 'uncertain' on the new one.</a:t>
+              <a:t>SAY: The obvious question from a commercial audience: why not just use ChatGPT? So we ran a fair contest, same questions, scored against real data, decided in advance. Two honest findings. One: on well-known drugs the LLMs are genuinely good, sometimes better than us. Two: when we checked the specific evidence they cited, database IDs for the molecules, 45% were fabricated or pointed to a completely different drug (one 'rasagiline' ID was actually a steroid). And for a brand-new, unpublished molecule, all four confidently made up an answer, and disagreed with each other. Our tool cited real measurements every time and said 'uncertain' on the new one.</a:t>
             </a:r>
           </a:p>
           <a:p/>
@@ -1031,7 +1031,7 @@
           <a:p/>
           <a:p>
             <a:r>
-              <a:t>Q&amp;A — EXPERT:</a:t>
+              <a:t>Q&amp;A, EXPERT:</a:t>
             </a:r>
           </a:p>
           <a:p>
@@ -1047,7 +1047,7 @@
           <a:p/>
           <a:p>
             <a:r>
-              <a:t>Q&amp;A — GENERAL/COMMERCIAL:</a:t>
+              <a:t>Q&amp;A, GENERAL/COMMERCIAL:</a:t>
             </a:r>
           </a:p>
           <a:p>
@@ -1057,7 +1057,7 @@
           </a:p>
           <a:p>
             <a:r>
-              <a:t>A: No — great for summarising known drugs. But for decisions needing traceable evidence or novel chemistry, a grounded tool is essential. They're complementary.</a:t>
+              <a:t>A: No, great for summarising known drugs. But for decisions needing traceable evidence or novel chemistry, a grounded tool is essential. They're complementary.</a:t>
             </a:r>
           </a:p>
         </p:txBody>
@@ -1133,7 +1133,7 @@
           <a:p/>
           <a:p>
             <a:r>
-              <a:t>Q&amp;A — EXPERT:</a:t>
+              <a:t>Q&amp;A, EXPERT:</a:t>
             </a:r>
           </a:p>
           <a:p>
@@ -1143,13 +1143,13 @@
           </a:p>
           <a:p>
             <a:r>
-              <a:t>A: Yes — deliberately: it returns the actual measured analogue and value, which is verifiable, unlike an LLM's fabricated citation.</a:t>
+              <a:t>A: Yes, deliberately: it returns the actual measured analogue and value, which is verifiable, unlike an LLM's fabricated citation.</a:t>
             </a:r>
           </a:p>
           <a:p/>
           <a:p>
             <a:r>
-              <a:t>Q&amp;A — GENERAL/COMMERCIAL:</a:t>
+              <a:t>Q&amp;A, GENERAL/COMMERCIAL:</a:t>
             </a:r>
           </a:p>
           <a:p>
@@ -1159,7 +1159,7 @@
           </a:p>
           <a:p>
             <a:r>
-              <a:t>A: 'A brain-drug triage tool you can audit — every answer backed by a real measurement, with honest confidence.'</a:t>
+              <a:t>A: 'A brain-drug triage tool you can audit, every answer backed by a real measurement, with honest confidence.'</a:t>
             </a:r>
           </a:p>
         </p:txBody>
@@ -1251,7 +1251,7 @@
           <a:p/>
           <a:p>
             <a:r>
-              <a:t>Q&amp;A — GENERAL/COMMERCIAL:</a:t>
+              <a:t>Q&amp;A, GENERAL/COMMERCIAL:</a:t>
             </a:r>
           </a:p>
           <a:p>
@@ -1261,7 +1261,7 @@
           </a:p>
           <a:p>
             <a:r>
-              <a:t>A: No — and it never should. It shortlists candidates for scientists to test.</a:t>
+              <a:t>A: No, and it never should. It shortlists candidates for scientists to test.</a:t>
             </a:r>
           </a:p>
           <a:p>
@@ -1271,13 +1271,13 @@
           </a:p>
           <a:p>
             <a:r>
-              <a:t>A: Compound triage for CNS discovery, natural-product screening, and drug-repurposing prioritisation — reducing wasted lab spend.</a:t>
+              <a:t>A: Compound triage for CNS discovery, natural-product screening, and drug-repurposing prioritisation, reducing wasted lab spend.</a:t>
             </a:r>
           </a:p>
           <a:p/>
           <a:p>
             <a:r>
-              <a:t>Q&amp;A — EXPERT:</a:t>
+              <a:t>Q&amp;A, EXPERT:</a:t>
             </a:r>
           </a:p>
           <a:p>
@@ -1357,13 +1357,13 @@
           <a:lstStyle/>
           <a:p>
             <a:r>
-              <a:t>SAY: To close — we built a brain-effect predictor you can trust because you can check it. 64,474 real measurements, four levels of testing, a confidence promise that holds, and zero fabricated evidence. It matches the best on standard tests, is honest about the hard ones, and every answer traces back to a real experiment. Thank you — happy to take questions.</a:t>
+              <a:t>SAY: To close, we built a brain-effect predictor you can trust because you can check it. 64,474 real measurements, four levels of testing, a confidence promise that holds, and zero fabricated evidence. It matches the best on standard tests, is honest about the hard ones, and every answer traces back to a real experiment. Thank you ,  happy to take questions.</a:t>
             </a:r>
           </a:p>
           <a:p/>
           <a:p>
             <a:r>
-              <a:t>Q&amp;A — EXPERT:</a:t>
+              <a:t>Q&amp;A, EXPERT:</a:t>
             </a:r>
           </a:p>
           <a:p>
@@ -1379,7 +1379,7 @@
           <a:p/>
           <a:p>
             <a:r>
-              <a:t>Q&amp;A — GENERAL/COMMERCIAL:</a:t>
+              <a:t>Q&amp;A, GENERAL/COMMERCIAL:</a:t>
             </a:r>
           </a:p>
           <a:p>
@@ -1459,7 +1459,7 @@
           <a:lstStyle/>
           <a:p>
             <a:r>
-              <a:t>SAY: A common misconception is that 'will this help the brain?' is one question. It isn't. A molecule can be a perfect target-blocker and still be useless because it never reaches the brain — or dangerous because it affects the heart. You have to answer all of these together. Today those answers are scattered across separate tools that don't talk to each other.</a:t>
+              <a:t>SAY: A common misconception is that 'will this help the brain?' is one question. It isn't. A molecule can be a perfect target-blocker and still be useless because it never reaches the brain, or dangerous because it affects the heart. You have to answer all of these together. Today those answers are scattered across separate tools that don't talk to each other.</a:t>
             </a:r>
           </a:p>
           <a:p/>
@@ -1480,13 +1480,13 @@
           </a:p>
           <a:p>
             <a:r>
-              <a:t>- ADMET: absorption, distribution, metabolism, excretion, toxicity — the 'developability' properties.</a:t>
+              <a:t>- ADMET: absorption, distribution, metabolism, excretion, toxicity, the 'developability' properties.</a:t>
             </a:r>
           </a:p>
           <a:p/>
           <a:p>
             <a:r>
-              <a:t>Q&amp;A — GENERAL/COMMERCIAL:</a:t>
+              <a:t>Q&amp;A, GENERAL/COMMERCIAL:</a:t>
             </a:r>
           </a:p>
           <a:p>
@@ -1502,7 +1502,7 @@
           <a:p/>
           <a:p>
             <a:r>
-              <a:t>Q&amp;A — EXPERT:</a:t>
+              <a:t>Q&amp;A, EXPERT:</a:t>
             </a:r>
           </a:p>
           <a:p>
@@ -1512,7 +1512,7 @@
           </a:p>
           <a:p>
             <a:r>
-              <a:t>A: They cover BBB/ADMET well but not measured CNS-target activity, BBB-gated disease synthesis, calibrated uncertainty, or a linked safety axis — that combination is the gap.</a:t>
+              <a:t>A: They cover BBB/ADMET well but not measured CNS-target activity, BBB-gated disease synthesis, calibrated uncertainty, or a linked safety axis, that combination is the gap.</a:t>
             </a:r>
           </a:p>
         </p:txBody>
@@ -1582,7 +1582,7 @@
           <a:lstStyle/>
           <a:p>
             <a:r>
-              <a:t>SAY: We did not invent a new machine-learning algorithm — and that is deliberate. The scientific value here is engineering restraint: taking proven, trusted components and integrating them so the whole is honest and auditable. Three properties make it different from a black box: calibration, evidence-grounding, and brain-gating.</a:t>
+              <a:t>SAY: We did not invent a new machine-learning algorithm, and that is deliberate. The scientific value here is engineering restraint: taking proven, trusted components and integrating them so the whole is honest and auditable. Three properties make it different from a black box: calibration, evidence-grounding, and brain-gating.</a:t>
             </a:r>
           </a:p>
           <a:p/>
@@ -1598,7 +1598,7 @@
           </a:p>
           <a:p>
             <a:r>
-              <a:t>- Confidence range (conformal set): instead of one number, the tool can say 'confidently active' or 'uncertain — both possible', with a mathematical coverage guarantee.</a:t>
+              <a:t>- Confidence range (conformal set): instead of one number, the tool can say 'confidently active' or 'uncertain, both possible', with a mathematical coverage guarantee.</a:t>
             </a:r>
           </a:p>
           <a:p>
@@ -1609,7 +1609,7 @@
           <a:p/>
           <a:p>
             <a:r>
-              <a:t>Q&amp;A — EXPERT:</a:t>
+              <a:t>Q&amp;A, EXPERT:</a:t>
             </a:r>
           </a:p>
           <a:p>
@@ -1619,13 +1619,13 @@
           </a:p>
           <a:p>
             <a:r>
-              <a:t>A: The integrated, calibrated, conformal, BBB-gated, safety-aware, evidence-grounded configuration on measured data — no existing single tool provides it — plus a rigorous multi-regime validation.</a:t>
+              <a:t>A: The integrated, calibrated, conformal, BBB-gated, safety-aware, evidence-grounded configuration on measured data, no existing single tool provides it, plus a rigorous multi-regime validation.</a:t>
             </a:r>
           </a:p>
           <a:p/>
           <a:p>
             <a:r>
-              <a:t>Q&amp;A — GENERAL/COMMERCIAL:</a:t>
+              <a:t>Q&amp;A, GENERAL/COMMERCIAL:</a:t>
             </a:r>
           </a:p>
           <a:p>
@@ -1635,7 +1635,7 @@
           </a:p>
           <a:p>
             <a:r>
-              <a:t>A: The integration, the curated measured dataset, the honesty layer (calibration + provenance), and validated performance — hard to reproduce casually.</a:t>
+              <a:t>A: The integration, the curated measured dataset, the honesty layer (calibration + provenance), and validated performance, hard to reproduce casually.</a:t>
             </a:r>
           </a:p>
         </p:txBody>
@@ -1705,7 +1705,7 @@
           <a:lstStyle/>
           <a:p>
             <a:r>
-              <a:t>SAY: Everything the tool knows comes from real experiments in public databases — mainly ChEMBL, the standard repository of measured bioactivity, and B3DB for brain penetration. 64,474 measured records in total. This is the single most important integrity point: the foundation is measured, not scraped text.</a:t>
+              <a:t>SAY: Everything the tool knows comes from real experiments in public databases, mainly ChEMBL, the standard repository of measured bioactivity, and B3DB for brain penetration. 64,474 measured records in total. This is the single most important integrity point: the foundation is measured, not scraped text.</a:t>
             </a:r>
           </a:p>
           <a:p/>
@@ -1737,12 +1737,12 @@
           <a:p/>
           <a:p>
             <a:r>
-              <a:t>Q&amp;A — EXPERT:</a:t>
-            </a:r>
-          </a:p>
-          <a:p>
-            <a:r>
-              <a:t>Q: You pool IC50/Ki/Kd/EC50 — doesn't that mix assays?</a:t>
+              <a:t>Q&amp;A, EXPERT:</a:t>
+            </a:r>
+          </a:p>
+          <a:p>
+            <a:r>
+              <a:t>Q: You pool IC50/Ki/Kd/EC50, doesn't that mix assays?</a:t>
             </a:r>
           </a:p>
           <a:p>
@@ -1753,7 +1753,7 @@
           <a:p/>
           <a:p>
             <a:r>
-              <a:t>Q&amp;A — GENERAL/COMMERCIAL:</a:t>
+              <a:t>Q&amp;A, GENERAL/COMMERCIAL:</a:t>
             </a:r>
           </a:p>
           <a:p>
@@ -1833,7 +1833,7 @@
           <a:lstStyle/>
           <a:p>
             <a:r>
-              <a:t>SAY: The tool outputs a full brain profile: brain entry, several disease-relevant targets, a heart-safety flag, receptor strengths, antioxidant capacity, and drug-likeness. Two of these — druggability and CNS-MPO — are transparent chemistry rules, not machine learning.</a:t>
+              <a:t>SAY: The tool outputs a full brain profile: brain entry, several disease-relevant targets, a heart-safety flag, receptor strengths, antioxidant capacity, and drug-likeness. Two of these, druggability and CNS-MPO, are transparent chemistry rules, not machine learning.</a:t>
             </a:r>
           </a:p>
           <a:p/>
@@ -1849,7 +1849,7 @@
           </a:p>
           <a:p>
             <a:r>
-              <a:t>- hERG: a heart ion-channel; blocking it can cause dangerous arrhythmia — a classic safety red flag.</a:t>
+              <a:t>- hERG: a heart ion-channel; blocking it can cause dangerous arrhythmia, a classic safety red flag.</a:t>
             </a:r>
           </a:p>
           <a:p>
@@ -1870,7 +1870,7 @@
           <a:p/>
           <a:p>
             <a:r>
-              <a:t>Q&amp;A — EXPERT:</a:t>
+              <a:t>Q&amp;A, EXPERT:</a:t>
             </a:r>
           </a:p>
           <a:p>
@@ -1880,13 +1880,13 @@
           </a:p>
           <a:p>
             <a:r>
-              <a:t>A: 96–98% active-only data makes binary classification degenerate; a pre-set quality gate (MCC&gt;=0.45) routes them to potency regression instead — decided by data, not hand.</a:t>
+              <a:t>A: 96–98% active-only data makes binary classification degenerate; a pre-set quality gate (MCC&gt;=0.45) routes them to potency regression instead, decided by data, not hand.</a:t>
             </a:r>
           </a:p>
           <a:p/>
           <a:p>
             <a:r>
-              <a:t>Q&amp;A — GENERAL/COMMERCIAL:</a:t>
+              <a:t>Q&amp;A, GENERAL/COMMERCIAL:</a:t>
             </a:r>
           </a:p>
           <a:p>
@@ -1896,7 +1896,7 @@
           </a:p>
           <a:p>
             <a:r>
-              <a:t>A: Yes — the same pipeline extends to any target with enough measured data.</a:t>
+              <a:t>A: Yes, the same pipeline extends to any target with enough measured data.</a:t>
             </a:r>
           </a:p>
         </p:txBody>
@@ -1966,7 +1966,7 @@
           <a:lstStyle/>
           <a:p>
             <a:r>
-              <a:t>SAY: Computers can't read a chemical drawing directly, so we convert each molecule into numbers in two ways: a 'fingerprint' that records which small sub-structures are present, and 24 physical properties like size and greasiness. Then three different model types each make a prediction and we average their votes — like a panel of experts rather than one opinion.</a:t>
+              <a:t>SAY: Computers can't read a chemical drawing directly, so we convert each molecule into numbers in two ways: a 'fingerprint' that records which small sub-structures are present, and 24 physical properties like size and greasiness. Then three different model types each make a prediction and we average their votes, like a panel of experts rather than one opinion.</a:t>
             </a:r>
           </a:p>
           <a:p/>
@@ -1998,7 +1998,7 @@
           <a:p/>
           <a:p>
             <a:r>
-              <a:t>Q&amp;A — EXPERT:</a:t>
+              <a:t>Q&amp;A, EXPERT:</a:t>
             </a:r>
           </a:p>
           <a:p>
@@ -2014,7 +2014,7 @@
           <a:p/>
           <a:p>
             <a:r>
-              <a:t>Q&amp;A — GENERAL/COMMERCIAL:</a:t>
+              <a:t>Q&amp;A, GENERAL/COMMERCIAL:</a:t>
             </a:r>
           </a:p>
           <a:p>
@@ -2024,7 +2024,7 @@
           </a:p>
           <a:p>
             <a:r>
-              <a:t>A: No — it runs on a normal machine, which keeps it cheap and deployable.</a:t>
+              <a:t>A: No, it runs on a normal machine, which keeps it cheap and deployable.</a:t>
             </a:r>
           </a:p>
         </p:txBody>
@@ -2131,7 +2131,7 @@
           <a:p/>
           <a:p>
             <a:r>
-              <a:t>Q&amp;A — EXPERT:</a:t>
+              <a:t>Q&amp;A, EXPERT:</a:t>
             </a:r>
           </a:p>
           <a:p>
@@ -2141,13 +2141,13 @@
           </a:p>
           <a:p>
             <a:r>
-              <a:t>A: No — we re-labelled at several cuts and retrained; max AUROC spread was 0.109 and the deployed cut ~ the strict cut (robustness slide). The grey-zone drop is empirically justified.</a:t>
+              <a:t>A: No, we re-labelled at several cuts and retrained; max AUROC spread was 0.109 and the deployed cut ~ the strict cut (robustness slide). The grey-zone drop is empirically justified.</a:t>
             </a:r>
           </a:p>
           <a:p/>
           <a:p>
             <a:r>
-              <a:t>Q&amp;A — GENERAL/COMMERCIAL:</a:t>
+              <a:t>Q&amp;A, GENERAL/COMMERCIAL:</a:t>
             </a:r>
           </a:p>
           <a:p>
@@ -2157,7 +2157,7 @@
           </a:p>
           <a:p>
             <a:r>
-              <a:t>A: The tool flags it as 'out of domain' instead of pretending confidence — a safety feature, not a bug.</a:t>
+              <a:t>A: The tool flags it as 'out of domain' instead of pretending confidence, a safety feature, not a bug.</a:t>
             </a:r>
           </a:p>
         </p:txBody>
@@ -2227,7 +2227,7 @@
           <a:lstStyle/>
           <a:p>
             <a:r>
-              <a:t>SAY: Anyone can score well on an easy test. We ran four, each closer to real life. The 'random' test is the easy one most papers stop at. The toughest — 'temporal' — trains only on older molecules and tests on the newest ones, simulating genuine prospective use. We report all four on purpose.</a:t>
+              <a:t>SAY: Anyone can score well on an easy test. We ran four, each closer to real life. The 'random' test is the easy one most papers stop at. The toughest, 'temporal', trains only on older molecules and tests on the newest ones, simulating genuine prospective use. We report all four on purpose.</a:t>
             </a:r>
           </a:p>
           <a:p/>
@@ -2259,7 +2259,7 @@
           <a:p/>
           <a:p>
             <a:r>
-              <a:t>Q&amp;A — EXPERT:</a:t>
+              <a:t>Q&amp;A, EXPERT:</a:t>
             </a:r>
           </a:p>
           <a:p>
@@ -2275,7 +2275,7 @@
           <a:p/>
           <a:p>
             <a:r>
-              <a:t>Q&amp;A — GENERAL/COMMERCIAL:</a:t>
+              <a:t>Q&amp;A, GENERAL/COMMERCIAL:</a:t>
             </a:r>
           </a:p>
           <a:p>
@@ -2355,7 +2355,7 @@
           <a:lstStyle/>
           <a:p>
             <a:r>
-              <a:t>SAY: On the standard 'random' test the models score 0.94–0.98 — at or above published state of the art. On the harder tests they hold 0.87–0.95, and on the toughest 'future' test they range 0.61–0.92. We show the low numbers too — GSK-3β and MAO-A are the hardest and we flag them as lower-confidence.</a:t>
+              <a:t>SAY: On the standard 'random' test the models score 0.94–0.98, at or above published state of the art. On the harder tests they hold 0.87–0.95, and on the toughest 'future' test they range 0.61–0.92. We show the low numbers too, GSK-3β and MAO-A are the hardest and we flag them as lower-confidence.</a:t>
             </a:r>
           </a:p>
           <a:p/>
@@ -2371,13 +2371,13 @@
           </a:p>
           <a:p>
             <a:r>
-              <a:t>- 'Coverage 0.885–0.905': when the tool gives a 90% confidence set, it is right about 90% of the time — the promise is kept.</a:t>
+              <a:t>- 'Coverage 0.885–0.905': when the tool gives a 90% confidence set, it is right about 90% of the time, the promise is kept.</a:t>
             </a:r>
           </a:p>
           <a:p/>
           <a:p>
             <a:r>
-              <a:t>Q&amp;A — EXPERT:</a:t>
+              <a:t>Q&amp;A, EXPERT:</a:t>
             </a:r>
           </a:p>
           <a:p>
@@ -2393,7 +2393,7 @@
           <a:p/>
           <a:p>
             <a:r>
-              <a:t>Q&amp;A — GENERAL/COMMERCIAL:</a:t>
+              <a:t>Q&amp;A, GENERAL/COMMERCIAL:</a:t>
             </a:r>
           </a:p>
           <a:p>
@@ -2403,7 +2403,7 @@
           </a:p>
           <a:p>
             <a:r>
-              <a:t>A: Yes — for this kind of prediction it's strong; and unlike many tools we also tell you when to trust it.</a:t>
+              <a:t>A: Yes, for this kind of prediction it's strong; and unlike many tools we also tell you when to trust it.</a:t>
             </a:r>
           </a:p>
         </p:txBody>
@@ -5588,7 +5588,7 @@
                 </a:solidFill>
                 <a:latin typeface="Georgia"/>
               </a:rPr>
-              <a:t>Predicting a molecule's effect on the brain —</a:t>
+              <a:t>Predicting a molecule's effect on the brain</a:t>
             </a:r>
           </a:p>
           <a:p>
@@ -5649,7 +5649,7 @@
                 </a:solidFill>
                 <a:latin typeface="Calibri"/>
               </a:rPr>
-              <a:t>An evidence-grounded, calibrated, safety-aware predictor of central-nervous-system activity — built entirely on measured laboratory data, not guesswork.</a:t>
+              <a:t>An evidence-grounded, calibrated, safety-aware predictor of central-nervous-system activity, built entirely on measured laboratory data, not guesswork.</a:t>
             </a:r>
           </a:p>
         </p:txBody>
@@ -5759,7 +5759,7 @@
                 </a:solidFill>
                 <a:latin typeface="Consolas"/>
               </a:rPr>
-              <a:t>09 · RESULTS — STRENGTH &amp; DRUG-LIKENESS</a:t>
+              <a:t>09 · RESULTS, STRENGTH &amp; DRUG-LIKENESS</a:t>
             </a:r>
           </a:p>
         </p:txBody>
@@ -6554,7 +6554,7 @@
                 </a:solidFill>
                 <a:latin typeface="Calibri"/>
               </a:rPr>
-              <a:t>Druggability score — CNS drugs vs polar non-drugs</a:t>
+              <a:t>Druggability score, CNS drugs vs polar non-drugs</a:t>
             </a:r>
           </a:p>
         </p:txBody>
@@ -7380,7 +7380,7 @@
                 </a:solidFill>
                 <a:latin typeface="Calibri"/>
               </a:rPr>
-              <a:t>R² and Spearman measure how closely predicted strength tracks the real measured strength (1.0 = perfect ordering). For druggability, higher = more drug-like for the brain — caffeine and donepezil score high; table sugar and a cholesterol drug (not brain-aimed) score low, as expected.</a:t>
+              <a:t>R² and Spearman measure how closely predicted strength tracks the real measured strength (1.0 = perfect ordering). For druggability, higher = more drug-like for the brain, caffeine and donepezil score high; table sugar and a cholesterol drug (not brain-aimed) score low, as expected.</a:t>
             </a:r>
           </a:p>
         </p:txBody>
@@ -8197,7 +8197,7 @@
                 </a:solidFill>
                 <a:latin typeface="Calibri"/>
               </a:rPr>
-              <a:t>Beating a pure 'look up the most similar molecule' method is the key check that it has learned real structure–activity patterns — not just memorised look-alikes. This is also why it behaves differently from an LLM (next).</a:t>
+              <a:t>Beating a pure 'look up the most similar molecule' method is the key check that it has learned real structure–activity patterns, not just memorised look-alikes. This is also why it behaves differently from an LLM (next).</a:t>
             </a:r>
           </a:p>
         </p:txBody>
@@ -8351,7 +8351,7 @@
                 </a:solidFill>
                 <a:latin typeface="Georgia"/>
               </a:rPr>
-              <a:t>Three known risks — measured, not just mentioned</a:t>
+              <a:t>Three known risks, measured, not just mentioned</a:t>
             </a:r>
           </a:p>
         </p:txBody>
@@ -8657,7 +8657,7 @@
                 </a:solidFill>
                 <a:latin typeface="Calibri"/>
               </a:rPr>
-              <a:t>Retraining on one experiment type only vs the mix changed scores by ≤ 0.006 — mixing is safe on the common scale.</a:t>
+              <a:t>Retraining on one experiment type only vs the mix changed scores by ≤ 0.006, mixing is safe on the common scale.</a:t>
             </a:r>
           </a:p>
         </p:txBody>
@@ -8948,7 +8948,7 @@
                 </a:solidFill>
                 <a:latin typeface="Calibri"/>
               </a:rPr>
-              <a:t>instead of just listing caveats, we re-ran the whole pipeline to put a number on each risk. All three came back reassuring — and where the model is weak (very novel molecules), it warns you rather than guessing confidently.</a:t>
+              <a:t>instead of just listing caveats, we re-ran the whole pipeline to put a number on each risk. All three came back reassuring, and where the model is weak (very novel molecules), it warns you rather than guessing confidently.</a:t>
             </a:r>
           </a:p>
         </p:txBody>
@@ -9102,7 +9102,7 @@
                 </a:solidFill>
                 <a:latin typeface="Georgia"/>
               </a:rPr>
-              <a:t>We ran a fair, pre-registered contest — here's what happened</a:t>
+              <a:t>We ran a fair, pre-registered contest, here's what happened</a:t>
             </a:r>
           </a:p>
         </p:txBody>
@@ -9881,7 +9881,7 @@
                 </a:solidFill>
                 <a:latin typeface="Calibri"/>
               </a:rPr>
-              <a:t> — several match or beat us. We say so plainly.</a:t>
+              <a:t>, several match or beat us. We say so plainly.</a:t>
             </a:r>
           </a:p>
           <a:p>
@@ -9906,7 +9906,7 @@
                 </a:solidFill>
                 <a:latin typeface="Calibri"/>
               </a:rPr>
-              <a:t> — a cited 'rasagiline' ID was actually a steroid; a 'rivastigmine' ID was vitamin B6.</a:t>
+              <a:t>, a cited 'rasagiline' ID was actually a steroid; a 'rivastigmine' ID was vitamin B6.</a:t>
             </a:r>
           </a:p>
           <a:p>
@@ -9931,7 +9931,7 @@
                 </a:solidFill>
                 <a:latin typeface="Calibri"/>
               </a:rPr>
-              <a:t> a target and potency for an unpublished molecule — and disagreed.</a:t>
+              <a:t> a target and potency for an unpublished molecule, and disagreed.</a:t>
             </a:r>
           </a:p>
         </p:txBody>
@@ -9979,7 +9979,7 @@
                 </a:solidFill>
                 <a:latin typeface="Calibri"/>
               </a:rPr>
-              <a:t>They can't be trusted for verifiable evidence or for genuinely new molecules — exactly where discovery happens. BrainSafe grounds every answer in a real measurement.</a:t>
+              <a:t>They can't be trusted for verifiable evidence or for genuinely new molecules, exactly where discovery happens. BrainSafe grounds every answer in a real measurement.</a:t>
             </a:r>
           </a:p>
         </p:txBody>
@@ -10293,7 +10293,7 @@
                           </a:solidFill>
                           <a:latin typeface="Consolas"/>
                         </a:rPr>
-                        <a:t>yes — 64,474</a:t>
+                        <a:t>yes, 64,474</a:t>
                       </a:r>
                     </a:p>
                   </a:txBody>
@@ -10598,7 +10598,7 @@
                           </a:solidFill>
                           <a:latin typeface="Consolas"/>
                         </a:rPr>
-                        <a:t>no — invents</a:t>
+                        <a:t>no, invents</a:t>
                       </a:r>
                     </a:p>
                   </a:txBody>
@@ -11067,7 +11067,7 @@
                 </a:solidFill>
                 <a:latin typeface="Georgia"/>
               </a:rPr>
-              <a:t>A research triage engine — not a clinical oracle</a:t>
+              <a:t>A research triage engine, not a clinical oracle</a:t>
             </a:r>
           </a:p>
         </p:txBody>
@@ -11435,7 +11435,7 @@
                 </a:solidFill>
                 <a:latin typeface="Calibri"/>
               </a:rPr>
-              <a:t>Predicts whether a molecule engages a target — not whether it activates or blocks it.</a:t>
+              <a:t>Predicts whether a molecule engages a target, not whether it activates or blocks it.</a:t>
             </a:r>
           </a:p>
           <a:p>
@@ -12148,7 +12148,7 @@
                 </a:solidFill>
                 <a:latin typeface="Calibri"/>
               </a:rPr>
-              <a:t>A calibrated, evidence-grounded, brain-entry-gated predictor built entirely on measured public data — state-of-the-art-grade on like-for-like tests, fully transparent on the hard ones, and every claim traceable to a real measurement.</a:t>
+              <a:t>A calibrated, evidence-grounded, brain-entry-gated predictor built entirely on measured public data, state-of-the-art-grade on like-for-like tests, fully transparent on the hard ones, and every claim traceable to a real measurement.</a:t>
             </a:r>
           </a:p>
         </p:txBody>
@@ -12758,7 +12758,7 @@
                 </a:solidFill>
                 <a:latin typeface="Calibri"/>
               </a:rPr>
-              <a:t>the blood–brain barrier is the brain's security gate — most molecules can't pass. A compound has to clear that gate AND hit the right target AND be safe. Answering these one-at-a-time, in different tools, is slow and error-prone.</a:t>
+              <a:t>the blood–brain barrier is the brain's security gate, most molecules can't pass. A compound has to clear that gate AND hit the right target AND be safe. Answering these one-at-a-time, in different tools, is slow and error-prone.</a:t>
             </a:r>
           </a:p>
         </p:txBody>
@@ -12912,7 +12912,7 @@
                 </a:solidFill>
                 <a:latin typeface="Georgia"/>
               </a:rPr>
-              <a:t>The innovation is the integration — not a new algorithm</a:t>
+              <a:t>The innovation is the integration, not a new algorithm</a:t>
             </a:r>
           </a:p>
         </p:txBody>
@@ -12954,7 +12954,7 @@
                 </a:solidFill>
                 <a:latin typeface="Calibri"/>
               </a:rPr>
-              <a:t>Each individual piece is well established. Combining them into one transparent, measured-data brain profiler — that is the contribution.</a:t>
+              <a:t>Each individual piece is well established. Combining them into one transparent, measured-data brain profiler, that is the contribution.</a:t>
             </a:r>
           </a:p>
         </p:txBody>
@@ -13107,7 +13107,7 @@
                 </a:solidFill>
                 <a:latin typeface="Calibri"/>
               </a:rPr>
-              <a:t>Every probability is honest — a '90%' really behaves like 9-in-10 — and comes with a guaranteed confidence range.</a:t>
+              <a:t>Every probability is honest, a '90%' really behaves like 9-in-10, and comes with a guaranteed confidence range.</a:t>
             </a:r>
           </a:p>
         </p:txBody>
@@ -13260,7 +13260,7 @@
                 </a:solidFill>
                 <a:latin typeface="Calibri"/>
               </a:rPr>
-              <a:t>Every answer shows the nearest real, measured molecule it is based on — you can check the receipt.</a:t>
+              <a:t>Every answer shows the nearest real, measured molecule it is based on, you can check the receipt.</a:t>
             </a:r>
           </a:p>
         </p:txBody>
@@ -13567,7 +13567,7 @@
                 </a:solidFill>
                 <a:latin typeface="Georgia"/>
               </a:rPr>
-              <a:t>64,474 measured records — every one a real experiment</a:t>
+              <a:t>64,474 measured records, every one a real experiment</a:t>
             </a:r>
           </a:p>
         </p:txBody>
@@ -14068,7 +14068,7 @@
                 </a:solidFill>
                 <a:latin typeface="Calibri"/>
               </a:rPr>
-              <a:t>Public, reproducible sources — ChEMBL and B3DB.</a:t>
+              <a:t>Public, reproducible sources, ChEMBL and B3DB.</a:t>
             </a:r>
           </a:p>
           <a:p>
@@ -14256,7 +14256,7 @@
                 </a:solidFill>
                 <a:latin typeface="Calibri"/>
               </a:rPr>
-              <a:t>'measured' means someone physically tested each molecule in a lab and recorded the result. The tool learns from tens of thousands of these real results — it is not making things up from text on the internet.</a:t>
+              <a:t>'measured' means someone physically tested each molecule in a lab and recorded the result. The tool learns from tens of thousands of these real results, it is not making things up from text on the internet.</a:t>
             </a:r>
           </a:p>
         </p:txBody>
@@ -15258,7 +15258,7 @@
                 </a:solidFill>
                 <a:latin typeface="Calibri"/>
               </a:rPr>
-              <a:t>Why the split? The four receptors were 96–98% actives in the data — too lopsided for a fair yes/no model — so the tool ranks their strength instead. A quality gate decides this automatically.</a:t>
+              <a:t>Why the split? The four receptors were 96–98% actives in the data, too lopsided for a fair yes/no model, so the tool ranks their strength instead. A quality gate decides this automatically.</a:t>
             </a:r>
           </a:p>
         </p:txBody>
@@ -15412,7 +15412,7 @@
                 </a:solidFill>
                 <a:latin typeface="Georgia"/>
               </a:rPr>
-              <a:t>How the computer 'sees' a molecule — and learns</a:t>
+              <a:t>How the computer 'sees' a molecule, and learns</a:t>
             </a:r>
           </a:p>
         </p:txBody>
@@ -15536,7 +15536,7 @@
                 </a:solidFill>
                 <a:latin typeface="Calibri"/>
               </a:rPr>
-              <a:t> — a 1,024-bit 'barcode' of the molecule's building blocks.</a:t>
+              <a:t>, a 1,024-bit 'barcode' of the molecule's building blocks.</a:t>
             </a:r>
           </a:p>
           <a:p>
@@ -15570,7 +15570,7 @@
                 </a:solidFill>
                 <a:latin typeface="Calibri"/>
               </a:rPr>
-              <a:t> — size, greasiness, surface area, flexibility, drug-likeness.</a:t>
+              <a:t>, size, greasiness, surface area, flexibility, drug-likeness.</a:t>
             </a:r>
           </a:p>
           <a:p>
@@ -15719,7 +15719,7 @@
                 </a:solidFill>
                 <a:latin typeface="Calibri"/>
               </a:rPr>
-              <a:t>Random Forest — 300 decision trees</a:t>
+              <a:t>Random Forest, 300 decision trees</a:t>
             </a:r>
           </a:p>
           <a:p>
@@ -15744,7 +15744,7 @@
                 </a:solidFill>
                 <a:latin typeface="Calibri"/>
               </a:rPr>
-              <a:t>Extra Trees — 300 randomised trees</a:t>
+              <a:t>Extra Trees, 300 randomised trees</a:t>
             </a:r>
           </a:p>
           <a:p>
@@ -15769,7 +15769,7 @@
                 </a:solidFill>
                 <a:latin typeface="Calibri"/>
               </a:rPr>
-              <a:t>Gradient Boosting — 300 rounds</a:t>
+              <a:t>Gradient Boosting, 300 rounds</a:t>
             </a:r>
           </a:p>
           <a:p>
@@ -15794,7 +15794,7 @@
                 </a:solidFill>
                 <a:latin typeface="Calibri"/>
               </a:rPr>
-              <a:t> averaging three different learners is steadier and more accurate than any one — and beats simpler methods (shown next).</a:t>
+              <a:t> averaging three different learners is steadier and more accurate than any one, and beats simpler methods (shown next).</a:t>
             </a:r>
           </a:p>
         </p:txBody>
@@ -16545,7 +16545,7 @@
                 </a:solidFill>
                 <a:latin typeface="Calibri"/>
               </a:rPr>
-              <a:t>Scores are adjusted (isotonic) so a '0.9' behaves like a real 90% — not just a ranking.</a:t>
+              <a:t>Scores are adjusted (isotonic) so a '0.9' behaves like a real 90%, not just a ranking.</a:t>
             </a:r>
           </a:p>
         </p:txBody>
@@ -16980,7 +16980,7 @@
                 </a:solidFill>
                 <a:latin typeface="Calibri"/>
               </a:rPr>
-              <a:t>Familiar questions — the easy exam most papers report.</a:t>
+              <a:t>Familiar questions, the easy exam most papers report.</a:t>
             </a:r>
           </a:p>
         </p:txBody>
@@ -17490,7 +17490,7 @@
                 </a:solidFill>
                 <a:latin typeface="Calibri"/>
               </a:rPr>
-              <a:t>Trained on older compounds, tested on the newest — a true 'future' exam.</a:t>
+              <a:t>Trained on older compounds, tested on the newest, a true 'future' exam.</a:t>
             </a:r>
           </a:p>
         </p:txBody>
@@ -17600,7 +17600,7 @@
                 </a:solidFill>
                 <a:latin typeface="Consolas"/>
               </a:rPr>
-              <a:t>08 · RESULTS — THE YES/NO MODELS</a:t>
+              <a:t>08 · RESULTS, THE YES/NO MODELS</a:t>
             </a:r>
           </a:p>
         </p:txBody>

</xml_diff>